<commit_message>
deck master bullet glyph scrubbed
Co-Authored-By: Claude Fable 5.1 <noreply@anthropic.com>
</commit_message>
<xml_diff>
--- a/deck/momentive-bi-digest.pptx
+++ b/deck/momentive-bi-digest.pptx
@@ -2505,7 +2505,7 @@
           <a:spcPct val="20000"/>
         </a:spcBef>
         <a:buFont typeface="Arial" pitchFamily="34" charset="0"/>
-        <a:buChar char="–"/>
+        <a:buChar char="-"/>
         <a:defRPr sz="2800" kern="1200">
           <a:solidFill>
             <a:schemeClr val="tx1"/>
@@ -2535,7 +2535,7 @@
           <a:spcPct val="20000"/>
         </a:spcBef>
         <a:buFont typeface="Arial" pitchFamily="34" charset="0"/>
-        <a:buChar char="–"/>
+        <a:buChar char="-"/>
         <a:defRPr sz="2000" kern="1200">
           <a:solidFill>
             <a:schemeClr val="tx1"/>

</xml_diff>